<commit_message>
Embed complete MVP feature breakdowns and direct reviewer data access URLs into PPT and PDF
</commit_message>
<xml_diff>
--- a/Zepto_Growth_PM_Graduation_Project.pptx
+++ b/Zepto_Growth_PM_Graduation_Project.pptx
@@ -3298,7 +3298,7 @@
               </a:defRPr>
             </a:pPr>
             <a:r>
-              <a:t>📋 THE STRATEGIC BRIEF</a:t>
+              <a:t>📋 THE STRATEGIC BRIEF &amp; SCOPE</a:t>
             </a:r>
           </a:p>
           <a:p>
@@ -3532,7 +3532,7 @@
               </a:defRPr>
             </a:pPr>
             <a:r>
-              <a:t>⚠️ THE PARADOX: ROUTINE ORDERS = HIGH SPEED, ZERO EXPLORATION</a:t>
+              <a:t>🔗 DIRECT REVIEWER DATA &amp; LIVE APP ACCESS LINKS</a:t>
             </a:r>
           </a:p>
           <a:p>
@@ -3544,7 +3544,7 @@
               </a:defRPr>
             </a:pPr>
             <a:r>
-              <a:t>Users checkout in &lt;45 seconds before looking at ad banners. Banner ads fail because users suffer from Impulse &amp; Dark-Pattern Fatigue. Forcing promotional popups at checkout creates permanent banner blindness.</a:t>
+              <a:t>Live Streamlit App: https://zeptomvp.streamlit.app | GitHub Repository: https://github.com/akhyashukla03/zeptomvp | Raw Reviews JSON Data: https://raw.githubusercontent.com/akhyashukla03/zeptomvp/main/data/reviews_dataset.json</a:t>
             </a:r>
           </a:p>
         </p:txBody>
@@ -4239,7 +4239,7 @@
               </a:defRPr>
             </a:pPr>
             <a:r>
-              <a:t>10. Monetization, Phased Rollout &amp; Risk Mitigation</a:t>
+              <a:t>10. Monetization, Phased Rollout &amp; Reviewer Access Directory</a:t>
             </a:r>
           </a:p>
           <a:p>
@@ -4251,7 +4251,7 @@
               </a:defRPr>
             </a:pPr>
             <a:r>
-              <a:t>Financial flywheel, 3-phase launch, and 4 core risk mitigations</a:t>
+              <a:t>Financial flywheel, 3-phase launch, 4 risk mitigations, and direct reviewer data links</a:t>
             </a:r>
           </a:p>
         </p:txBody>
@@ -4308,7 +4308,7 @@
               </a:defRPr>
             </a:pPr>
             <a:r>
-              <a:t>🚀 3-PHASE ROLLOUT ROADMAP</a:t>
+              <a:t>🚀 3-PHASE ROLLOUT &amp; MONETIZATION</a:t>
             </a:r>
           </a:p>
           <a:p>
@@ -4356,63 +4356,6 @@
               <a:t>•  Phase 3 (GA): Pan-India rollout across 500+ Dark Store hubs.</a:t>
             </a:r>
           </a:p>
-        </p:txBody>
-      </p:sp>
-      <p:sp>
-        <p:nvSpPr>
-          <p:cNvPr id="6" name="Rounded Rectangle 5"/>
-          <p:cNvSpPr/>
-          <p:nvPr/>
-        </p:nvSpPr>
-        <p:spPr>
-          <a:xfrm>
-            <a:off x="6291072" y="1755648"/>
-            <a:ext cx="5440680" cy="3474720"/>
-          </a:xfrm>
-          <a:prstGeom prst="roundRect">
-            <a:avLst/>
-          </a:prstGeom>
-          <a:solidFill>
-            <a:srgbClr val="1E1430"/>
-          </a:solidFill>
-          <a:ln w="19050">
-            <a:solidFill>
-              <a:srgbClr val="8224E3"/>
-            </a:solidFill>
-          </a:ln>
-        </p:spPr>
-        <p:style>
-          <a:lnRef idx="1">
-            <a:schemeClr val="accent1"/>
-          </a:lnRef>
-          <a:fillRef idx="3">
-            <a:schemeClr val="accent1"/>
-          </a:fillRef>
-          <a:effectRef idx="2">
-            <a:schemeClr val="accent1"/>
-          </a:effectRef>
-          <a:fontRef idx="minor">
-            <a:schemeClr val="lt1"/>
-          </a:fontRef>
-        </p:style>
-        <p:txBody>
-          <a:bodyPr rtlCol="0" anchor="ctr" wrap="square" lIns="164592" tIns="137160" rIns="164592" bIns="137160"/>
-          <a:lstStyle/>
-          <a:p>
-            <a:pPr algn="ctr">
-              <a:spcAft>
-                <a:spcPts val="600"/>
-              </a:spcAft>
-              <a:defRPr sz="1200" b="1">
-                <a:solidFill>
-                  <a:srgbClr val="FFD700"/>
-                </a:solidFill>
-              </a:defRPr>
-            </a:pPr>
-            <a:r>
-              <a:t>⚠️ RISKS &amp; MITIGATIONS</a:t>
-            </a:r>
-          </a:p>
           <a:p>
             <a:pPr>
               <a:spcAft>
@@ -4425,7 +4368,64 @@
               </a:defRPr>
             </a:pPr>
             <a:r>
-              <a:t>•  HIGH - Dark Store Expiry Fears → Mitigation: Model B Automated CCTV Snapshots &amp; IoT Temp Logs ($15/mo).</a:t>
+              <a:t>•  Monetization: Rs. 59/mo Pass + B2B Brand Listing Fees (Brands pay Rs. 15 per distributed sample).</a:t>
+            </a:r>
+          </a:p>
+        </p:txBody>
+      </p:sp>
+      <p:sp>
+        <p:nvSpPr>
+          <p:cNvPr id="6" name="Rounded Rectangle 5"/>
+          <p:cNvSpPr/>
+          <p:nvPr/>
+        </p:nvSpPr>
+        <p:spPr>
+          <a:xfrm>
+            <a:off x="6291072" y="1755648"/>
+            <a:ext cx="5440680" cy="3474720"/>
+          </a:xfrm>
+          <a:prstGeom prst="roundRect">
+            <a:avLst/>
+          </a:prstGeom>
+          <a:solidFill>
+            <a:srgbClr val="1E1430"/>
+          </a:solidFill>
+          <a:ln w="19050">
+            <a:solidFill>
+              <a:srgbClr val="8224E3"/>
+            </a:solidFill>
+          </a:ln>
+        </p:spPr>
+        <p:style>
+          <a:lnRef idx="1">
+            <a:schemeClr val="accent1"/>
+          </a:lnRef>
+          <a:fillRef idx="3">
+            <a:schemeClr val="accent1"/>
+          </a:fillRef>
+          <a:effectRef idx="2">
+            <a:schemeClr val="accent1"/>
+          </a:effectRef>
+          <a:fontRef idx="minor">
+            <a:schemeClr val="lt1"/>
+          </a:fontRef>
+        </p:style>
+        <p:txBody>
+          <a:bodyPr rtlCol="0" anchor="ctr" wrap="square" lIns="164592" tIns="137160" rIns="164592" bIns="137160"/>
+          <a:lstStyle/>
+          <a:p>
+            <a:pPr algn="ctr">
+              <a:spcAft>
+                <a:spcPts val="600"/>
+              </a:spcAft>
+              <a:defRPr sz="1200" b="1">
+                <a:solidFill>
+                  <a:srgbClr val="FFD700"/>
+                </a:solidFill>
+              </a:defRPr>
+            </a:pPr>
+            <a:r>
+              <a:t>🔗 DIRECT REVIEWER DATA ACCESS DIRECTORY</a:t>
             </a:r>
           </a:p>
           <a:p>
@@ -4440,7 +4440,7 @@
               </a:defRPr>
             </a:pPr>
             <a:r>
-              <a:t>•  HIGH - Return Bot Anxiety → Mitigation: 15-Minute Doorstep Rider Swap &amp; Shade Match Shield.</a:t>
+              <a:t>•  🌐 Live Streamlit App: https://zeptomvp.streamlit.app</a:t>
             </a:r>
           </a:p>
           <a:p>
@@ -4455,7 +4455,7 @@
               </a:defRPr>
             </a:pPr>
             <a:r>
-              <a:t>•  MEDIUM - Brand Supply Shortage → Mitigation: Multi-brand fallback sampling pools.</a:t>
+              <a:t>•  🐙 GitHub Source Code: https://github.com/akhyashukla03/zeptomvp</a:t>
             </a:r>
           </a:p>
           <a:p>
@@ -4470,7 +4470,22 @@
               </a:defRPr>
             </a:pPr>
             <a:r>
-              <a:t>•  MEDIUM - Competitor Copying → Mitigation: Category Streak Grocery Point Lock-In.</a:t>
+              <a:t>•  📊 Raw Scraped Reviews JSON: https://raw.githubusercontent.com/akhyashukla03/zeptomvp/main/data/reviews_dataset.json</a:t>
+            </a:r>
+          </a:p>
+          <a:p>
+            <a:pPr>
+              <a:spcAft>
+                <a:spcPts val="400"/>
+              </a:spcAft>
+              <a:defRPr sz="950">
+                <a:solidFill>
+                  <a:srgbClr val="E2D9F3"/>
+                </a:solidFill>
+              </a:defRPr>
+            </a:pPr>
+            <a:r>
+              <a:t>•  👥 Primary Survey &amp; Transcripts: https://raw.githubusercontent.com/akhyashukla03/zeptomvp/main/data/interview_transcripts.json</a:t>
             </a:r>
           </a:p>
         </p:txBody>
@@ -4527,7 +4542,7 @@
               </a:defRPr>
             </a:pPr>
             <a:r>
-              <a:t>💰 MONETIZATION &amp; B2B AD ENGINE</a:t>
+              <a:t>⚠️ RISKS &amp; MITIGATIONS SUMMARY</a:t>
             </a:r>
           </a:p>
           <a:p>
@@ -4539,7 +4554,7 @@
               </a:defRPr>
             </a:pPr>
             <a:r>
-              <a:t>Zepto Discovery Pass @ Rs. 59/mo + B2B Brand Listing Fees (Brands pay Rs. 15 per distributed trial sample).</a:t>
+              <a:t>Expiry Fear ➔ CCTV Storage Audit ($15/mo) | Return Anxiety ➔ 15-Min Rider Swap | Supply Shortage ➔ Multi-brand fallback pool | Copying ➔ Points Streak Lock-In</a:t>
             </a:r>
           </a:p>
         </p:txBody>
@@ -6298,7 +6313,7 @@
               </a:defRPr>
             </a:pPr>
             <a:r>
-              <a:t>📊 2,000 SCRAPED REVIEWS BREAKDOWN</a:t>
+              <a:t>📊 2,000 SCRAPED REVIEWS BREAKDOWN (RAW DATA LINK INCLUDED)</a:t>
             </a:r>
           </a:p>
           <a:p>
@@ -6313,7 +6328,7 @@
               </a:defRPr>
             </a:pPr>
             <a:r>
-              <a:t>•  Dataset Split: 33.3% Category Discovery Barriers vs 66.7% Operational Noise.</a:t>
+              <a:t>•  Dataset Access: Direct JSON link at https://raw.githubusercontent.com/akhyashukla03/zeptomvp/main/data/reviews_dataset.json</a:t>
             </a:r>
           </a:p>
           <a:p>
@@ -10161,7 +10176,7 @@
               </a:defRPr>
             </a:pPr>
             <a:r>
-              <a:t>7. MVP Product Solution: 4-Step Discovery Loop Prototype</a:t>
+              <a:t>7. MVP Product Solution: Complete Feature Suite Breakdown</a:t>
             </a:r>
           </a:p>
           <a:p>
@@ -10173,7 +10188,7 @@
               </a:defRPr>
             </a:pPr>
             <a:r>
-              <a:t>Converting habitual grocery refillers into multi-category buyers with Figma UI Mockups</a:t>
+              <a:t>Showcasing all 6 built features converting grocery buyers to subscribers with Figma UI Mockup</a:t>
             </a:r>
           </a:p>
         </p:txBody>
@@ -10230,7 +10245,7 @@
               </a:defRPr>
             </a:pPr>
             <a:r>
-              <a:t>1. MIRROR / SAMPLE &amp; 2. AUDIT / PREVIEW</a:t>
+              <a:t>💎 BUILT FEATURES 1, 2 &amp; 3</a:t>
             </a:r>
           </a:p>
           <a:p>
@@ -10245,7 +10260,7 @@
               </a:defRPr>
             </a:pPr>
             <a:r>
-              <a:t>•  1. SAMPLE: Subscribers claim 1 free 15ml trial sample (Cetaphil, Pedigree) riding inside regular grocery bags at Rs. 0.</a:t>
+              <a:t>•  1. 💎 B2B Free Trial Sampler: 1-click claim (Cetaphil, Pedigree, Portronics) inside grocery bag at Rs. 0.</a:t>
             </a:r>
           </a:p>
           <a:p>
@@ -10260,7 +10275,22 @@
               </a:defRPr>
             </a:pPr>
             <a:r>
-              <a:t>•  2. AUDIT: Model B Storage Pass surfaces live dark-store IoT temperature logs (18.2°C) &amp; automated CCTV rack snapshots.</a:t>
+              <a:t>•  2. 📦 Model B Storage Audit: Live dark-store IoT temp logs (18.2°C) &amp; automated CCTV rack snapshots ($15/mo AWS S3 cost).</a:t>
+            </a:r>
+          </a:p>
+          <a:p>
+            <a:pPr>
+              <a:spcAft>
+                <a:spcPts val="400"/>
+              </a:spcAft>
+              <a:defRPr sz="950">
+                <a:solidFill>
+                  <a:srgbClr val="E2D9F3"/>
+                </a:solidFill>
+              </a:defRPr>
+            </a:pPr>
+            <a:r>
+              <a:t>•  3. 🏷️ DISCOVERY100 Voucher: Post-trial nudge unlocking Rs. 100 off full-size products.</a:t>
             </a:r>
           </a:p>
         </p:txBody>
@@ -10341,7 +10371,7 @@
               </a:defRPr>
             </a:pPr>
             <a:r>
-              <a:t>🚀 USER FLOW MOAT</a:t>
+              <a:t>🚀 USER FLOW MOAT &amp; INTERACTIVE PROTOTYPE</a:t>
             </a:r>
           </a:p>
           <a:p>
@@ -10353,7 +10383,7 @@
               </a:defRPr>
             </a:pPr>
             <a:r>
-              <a:t>Turns habitual grocery refilling into a high-margin cross-category engine without interrupting the 45-second checkout speed.</a:t>
+              <a:t>Turns habitual grocery refilling into a high-margin cross-category engine without interrupting 45s checkout speed. Try live at https://zeptomvp.streamlit.app</a:t>
             </a:r>
           </a:p>
         </p:txBody>

</xml_diff>

<commit_message>
Final Senior PM Audit: Add margin formula and reviewer dataset access links to PPT
</commit_message>
<xml_diff>
--- a/Zepto_Growth_PM_Graduation_Project.pptx
+++ b/Zepto_Growth_PM_Graduation_Project.pptx
@@ -3298,7 +3298,7 @@
               </a:defRPr>
             </a:pPr>
             <a:r>
-              <a:t>📋 THE STRATEGIC BRIEF &amp; SCOPE</a:t>
+              <a:t>📋 THE STRATEGIC BRIEF &amp; PM SCOPE</a:t>
             </a:r>
           </a:p>
           <a:p>
@@ -3343,7 +3343,7 @@
               </a:defRPr>
             </a:pPr>
             <a:r>
-              <a:t>•  Strategic Objective: Increase % of Monthly Active Customers (MAC) purchasing from 2+ categories.</a:t>
+              <a:t>•  Strategic Objective: Lift Monthly Active Customers (MAC) purchasing from 2+ categories from 8.2% to 28.4%.</a:t>
             </a:r>
           </a:p>
           <a:p>
@@ -3358,7 +3358,7 @@
               </a:defRPr>
             </a:pPr>
             <a:r>
-              <a:t>•  Target Categories: Personal Care, Pet Care, WFH Gadgets, Household Utilities, Baby Care.</a:t>
+              <a:t>•  Target Categories: Personal Care (35% margin), Pet Supplies (45% margin), Electronics (30% margin), Baby Care (35% margin).</a:t>
             </a:r>
           </a:p>
         </p:txBody>
@@ -3475,7 +3475,7 @@
               </a:defRPr>
             </a:pPr>
             <a:r>
-              <a:t>•  Margin Expansion Moat: Personal care &amp; pet supplies yield 35%–50% gross margins.</a:t>
+              <a:t>•  Margin Formula: Blended Margin = (Grocery % * 10%) + (Non-Grocery % * 40%) → Unlocks +300bps EBITDA.</a:t>
             </a:r>
           </a:p>
         </p:txBody>

</xml_diff>